<commit_message>
Refresh screenshots and slides for the redesigned dashboard
</commit_message>
<xml_diff>
--- a/docs/Presentation.pptx
+++ b/docs/Presentation.pptx
@@ -123,19 +123,19 @@
   <p:extLst>
     <p:ext uri="{521415D9-36F7-43E2-AB2F-B90AF26B5E84}">
       <p14:sectionLst xmlns:p14="http://schemas.microsoft.com/office/powerpoint/2010/main">
-        <p14:section name="Opening" id="{d3bc6984-4939-37fd-01c4-c902926ee664}">
+        <p14:section name="Opening" id="{8ee3164f-b93b-b7dd-e8dd-4d0d212a5425}">
           <p14:sldIdLst>
             <p14:sldId id="256"/>
             <p14:sldId id="257"/>
           </p14:sldIdLst>
         </p14:section>
-        <p14:section name="Problem" id="{a53122ac-50d1-ffa7-c5ff-99ab6b9bf030}">
+        <p14:section name="Problem" id="{93d529ef-6abd-e69d-629d-9ab4a52e5a36}">
           <p14:sldIdLst>
             <p14:sldId id="258"/>
             <p14:sldId id="259"/>
           </p14:sldIdLst>
         </p14:section>
-        <p14:section name="The twin" id="{dcd6e644-35de-0fae-ab18-bbaeda20c14e}">
+        <p14:section name="The twin" id="{d967e55e-9415-741e-de7f-2eab8a3a21be}">
           <p14:sldIdLst>
             <p14:sldId id="260"/>
             <p14:sldId id="261"/>
@@ -143,13 +143,13 @@
             <p14:sldId id="263"/>
           </p14:sldIdLst>
         </p14:section>
-        <p14:section name="In the clinic" id="{38ba0201-9879-4bd3-dda6-06ba2a363f0e}">
+        <p14:section name="In the clinic" id="{ef0cd982-7178-7c35-77bd-80e5b73e5226}">
           <p14:sldIdLst>
             <p14:sldId id="264"/>
             <p14:sldId id="265"/>
           </p14:sldIdLst>
         </p14:section>
-        <p14:section name="Evidence" id="{1ebd5232-a5eb-13bd-5531-25e7f76729b5}">
+        <p14:section name="Evidence" id="{8ffa6d1d-e6b7-f5df-e5e5-e35cdab771be}">
           <p14:sldIdLst>
             <p14:sldId id="266"/>
             <p14:sldId id="267"/>
@@ -157,17 +157,17 @@
             <p14:sldId id="269"/>
           </p14:sldIdLst>
         </p14:section>
-        <p14:section name="India" id="{68717554-ced1-0dc0-58ac-976ea56ab5e7}">
+        <p14:section name="India" id="{e0743426-52d3-8b3e-7041-1cd19e7fe7e6}">
           <p14:sldIdLst>
             <p14:sldId id="270"/>
           </p14:sldIdLst>
         </p14:section>
-        <p14:section name="Next" id="{4f2fa862-aee0-76dc-d97f-d41b4627eb1a}">
+        <p14:section name="Next" id="{9ec93612-a703-758f-c220-f30b55c8236a}">
           <p14:sldIdLst>
             <p14:sldId id="271"/>
           </p14:sldIdLst>
         </p14:section>
-        <p14:section name="Close" id="{50e922b0-190e-2d4d-e604-9e54ab67315e}">
+        <p14:section name="Close" id="{5bc85a1e-0023-f1c4-348e-ab4ca90fadce}">
           <p14:sldIdLst>
             <p14:sldId id="272"/>
           </p14:sldIdLst>

</xml_diff>

<commit_message>
Update screenshots, slides and docs for the dashboard design changes
</commit_message>
<xml_diff>
--- a/docs/Presentation.pptx
+++ b/docs/Presentation.pptx
@@ -124,19 +124,19 @@
   <p:extLst>
     <p:ext uri="{521415D9-36F7-43E2-AB2F-B90AF26B5E84}">
       <p14:sectionLst xmlns:p14="http://schemas.microsoft.com/office/powerpoint/2010/main">
-        <p14:section name="Opening" id="{39ab578a-5032-c49b-1d99-08bd232643c0}">
+        <p14:section name="Opening" id="{cda7daff-2cb0-ed1a-be30-b0e73a6d736b}">
           <p14:sldIdLst>
             <p14:sldId id="256"/>
             <p14:sldId id="257"/>
           </p14:sldIdLst>
         </p14:section>
-        <p14:section name="Problem" id="{4ca43d6e-fcb9-7e38-e44d-e3127700318a}">
+        <p14:section name="Problem" id="{9792af93-1e63-c841-a382-b521f6b6d828}">
           <p14:sldIdLst>
             <p14:sldId id="258"/>
             <p14:sldId id="259"/>
           </p14:sldIdLst>
         </p14:section>
-        <p14:section name="The twin" id="{8806a3ea-7a35-6c04-ecf0-666e1a98915f}">
+        <p14:section name="The twin" id="{19c63511-8ca9-b3a3-4418-1648b2de0160}">
           <p14:sldIdLst>
             <p14:sldId id="260"/>
             <p14:sldId id="261"/>
@@ -144,14 +144,14 @@
             <p14:sldId id="263"/>
           </p14:sldIdLst>
         </p14:section>
-        <p14:section name="In the clinic" id="{b02d4384-4a2f-5d9d-a336-106df3f536d5}">
+        <p14:section name="In the clinic" id="{70645bee-047e-085a-be31-1d32cef72833}">
           <p14:sldIdLst>
             <p14:sldId id="264"/>
             <p14:sldId id="265"/>
             <p14:sldId id="266"/>
           </p14:sldIdLst>
         </p14:section>
-        <p14:section name="Evidence" id="{d1770f61-f8ee-0e91-a0b5-992c98123dbf}">
+        <p14:section name="Evidence" id="{76b0f7bb-2e4f-1d38-688f-04df844aa5aa}">
           <p14:sldIdLst>
             <p14:sldId id="267"/>
             <p14:sldId id="268"/>
@@ -159,17 +159,17 @@
             <p14:sldId id="270"/>
           </p14:sldIdLst>
         </p14:section>
-        <p14:section name="India" id="{b757b3ab-23ad-224c-2dde-7edfd31abfd5}">
+        <p14:section name="India" id="{1e1d41a3-a7d3-e193-20de-62773d84b548}">
           <p14:sldIdLst>
             <p14:sldId id="271"/>
           </p14:sldIdLst>
         </p14:section>
-        <p14:section name="Next" id="{b5da0390-eb60-944e-cde8-c7ab2efe90e7}">
+        <p14:section name="Next" id="{5ea1ffc2-4aac-34bd-c539-f252cbaa469b}">
           <p14:sldIdLst>
             <p14:sldId id="272"/>
           </p14:sldIdLst>
         </p14:section>
-        <p14:section name="Close" id="{2f7964dd-0095-d1b7-7a07-501c6e84cf6d}">
+        <p14:section name="Close" id="{dc82dabc-1fdc-9096-9e2b-1424659ce066}">
           <p14:sldIdLst>
             <p14:sldId id="273"/>
           </p14:sldIdLst>

</xml_diff>

<commit_message>
Add the repository link to the closing slide
</commit_message>
<xml_diff>
--- a/docs/Presentation.pptx
+++ b/docs/Presentation.pptx
@@ -124,19 +124,19 @@
   <p:extLst>
     <p:ext uri="{521415D9-36F7-43E2-AB2F-B90AF26B5E84}">
       <p14:sectionLst xmlns:p14="http://schemas.microsoft.com/office/powerpoint/2010/main">
-        <p14:section name="Opening" id="{cda7daff-2cb0-ed1a-be30-b0e73a6d736b}">
+        <p14:section name="Opening" id="{dbaa2bf8-6f6c-7b1c-2af7-39a0785ba417}">
           <p14:sldIdLst>
             <p14:sldId id="256"/>
             <p14:sldId id="257"/>
           </p14:sldIdLst>
         </p14:section>
-        <p14:section name="Problem" id="{9792af93-1e63-c841-a382-b521f6b6d828}">
+        <p14:section name="Problem" id="{3d467954-4227-62c1-a2ec-0d2a55d5d45e}">
           <p14:sldIdLst>
             <p14:sldId id="258"/>
             <p14:sldId id="259"/>
           </p14:sldIdLst>
         </p14:section>
-        <p14:section name="The twin" id="{19c63511-8ca9-b3a3-4418-1648b2de0160}">
+        <p14:section name="The twin" id="{49e419e4-9430-c1c9-ea3f-4ed07e92c6cc}">
           <p14:sldIdLst>
             <p14:sldId id="260"/>
             <p14:sldId id="261"/>
@@ -144,14 +144,14 @@
             <p14:sldId id="263"/>
           </p14:sldIdLst>
         </p14:section>
-        <p14:section name="In the clinic" id="{70645bee-047e-085a-be31-1d32cef72833}">
+        <p14:section name="In the clinic" id="{7c3ca502-f4e7-17f0-782e-846f174347b7}">
           <p14:sldIdLst>
             <p14:sldId id="264"/>
             <p14:sldId id="265"/>
             <p14:sldId id="266"/>
           </p14:sldIdLst>
         </p14:section>
-        <p14:section name="Evidence" id="{76b0f7bb-2e4f-1d38-688f-04df844aa5aa}">
+        <p14:section name="Evidence" id="{290b25fd-1cbb-8a45-1d45-a6719d9ca90f}">
           <p14:sldIdLst>
             <p14:sldId id="267"/>
             <p14:sldId id="268"/>
@@ -159,17 +159,17 @@
             <p14:sldId id="270"/>
           </p14:sldIdLst>
         </p14:section>
-        <p14:section name="India" id="{1e1d41a3-a7d3-e193-20de-62773d84b548}">
+        <p14:section name="India" id="{e97592d4-5b29-f5cc-26f0-b2e6f85a700e}">
           <p14:sldIdLst>
             <p14:sldId id="271"/>
           </p14:sldIdLst>
         </p14:section>
-        <p14:section name="Next" id="{5ea1ffc2-4aac-34bd-c539-f252cbaa469b}">
+        <p14:section name="Next" id="{343482b4-ab7c-388a-1595-996755382e74}">
           <p14:sldIdLst>
             <p14:sldId id="272"/>
           </p14:sldIdLst>
         </p14:section>
-        <p14:section name="Close" id="{dc82dabc-1fdc-9096-9e2b-1424659ce066}">
+        <p14:section name="Close" id="{3e8b1325-a3ce-0842-62bb-0a291211cbbc}">
           <p14:sldIdLst>
             <p14:sldId id="273"/>
           </p14:sldIdLst>
@@ -10853,6 +10853,23 @@
                 <a:cs typeface="Segoe UI" pitchFamily="34" charset="-120"/>
               </a:rPr>
               <a:t>Team BioT   ·   Anish Karthik Ayyagari   ·   Indian Institute of Technology Kharagpur</a:t>
+            </a:r>
+            <a:endParaRPr lang="en-US" sz="1500" dirty="0"/>
+          </a:p>
+          <a:p>
+            <a:pPr algn="l" indent="0" marL="0">
+              <a:buNone/>
+            </a:pPr>
+            <a:r>
+              <a:rPr lang="en-US" sz="1500" dirty="0">
+                <a:solidFill>
+                  <a:srgbClr val="C9D3E0"/>
+                </a:solidFill>
+                <a:latin typeface="Segoe UI" pitchFamily="34" charset="0"/>
+                <a:ea typeface="Segoe UI" pitchFamily="34" charset="-122"/>
+                <a:cs typeface="Segoe UI" pitchFamily="34" charset="-120"/>
+              </a:rPr>
+              <a:t>github.com/Realmer01/BioT_IIT_Kharagpur</a:t>
             </a:r>
             <a:endParaRPr lang="en-US" sz="1500" dirty="0"/>
           </a:p>

</xml_diff>